<commit_message>
docs(Presentacion, informe) y feat(etl): actualizacion de Presentacion e informe con parte de proceso ETL, agreado como proceso final de ETL validacion automatica con script sql
</commit_message>
<xml_diff>
--- a/docs/presentacion/Kent Foods – Fase 1.pptx
+++ b/docs/presentacion/Kent Foods – Fase 1.pptx
@@ -5,7 +5,7 @@
     <p:sldMasterId id="2147483648" r:id="rId1"/>
   </p:sldMasterIdLst>
   <p:notesMasterIdLst>
-    <p:notesMasterId r:id="rId13"/>
+    <p:notesMasterId r:id="rId14"/>
   </p:notesMasterIdLst>
   <p:sldIdLst>
     <p:sldId id="256" r:id="rId2"/>
@@ -19,6 +19,7 @@
     <p:sldId id="264" r:id="rId10"/>
     <p:sldId id="265" r:id="rId11"/>
     <p:sldId id="266" r:id="rId12"/>
+    <p:sldId id="267" r:id="rId13"/>
   </p:sldIdLst>
   <p:sldSz cx="12192000" cy="6858000"/>
   <p:notesSz cx="6858000" cy="12192000"/>
@@ -380,7 +381,15 @@
           <a:p>
             <a:r>
               <a:rPr lang="en-US" dirty="0"/>
-              <a:t>También: 91 clientes, 77 productos, 9 empleados, 3 transportistas, 21 órdenes con FechaEnvioKey −1. Ventas por año: 2016 208.083,95 · 2017 617.085,05 · 2018 440.623,76.</a:t>
+              <a:t>También: 91 clientes, 77 </a:t>
+            </a:r>
+            <a:r>
+              <a:rPr lang="en-US" dirty="0" err="1"/>
+              <a:t>productos</a:t>
+            </a:r>
+            <a:r>
+              <a:rPr lang="en-US" dirty="0"/>
+              <a:t>, 9 empleados, 3 transportistas, 21 órdenes con FechaEnvioKey −1. Ventas por año: 2016 208.083,95 · 2017 617.085,05 · 2018 440.623,76.</a:t>
             </a:r>
           </a:p>
         </p:txBody>
@@ -508,6 +517,93 @@
 </p:notes>
 </file>
 
+<file path=ppt/notesSlides/notesSlide12.xml><?xml version="1.0" encoding="utf-8"?>
+<p:notes xmlns:a="http://schemas.openxmlformats.org/drawingml/2006/main" xmlns:r="http://schemas.openxmlformats.org/officeDocument/2006/relationships" xmlns:p="http://schemas.openxmlformats.org/presentationml/2006/main">
+  <p:cSld>
+    <p:spTree>
+      <p:nvGrpSpPr>
+        <p:cNvPr id="1" name=""/>
+        <p:cNvGrpSpPr/>
+        <p:nvPr/>
+      </p:nvGrpSpPr>
+      <p:grpSpPr>
+        <a:xfrm>
+          <a:off x="0" y="0"/>
+          <a:ext cx="0" cy="0"/>
+          <a:chOff x="0" y="0"/>
+          <a:chExt cx="0" cy="0"/>
+        </a:xfrm>
+      </p:grpSpPr>
+      <p:sp>
+        <p:nvSpPr>
+          <p:cNvPr id="2" name="Slide Image Placeholder 1"/>
+          <p:cNvSpPr>
+            <a:spLocks noGrp="1" noRot="1" noChangeAspect="1"/>
+          </p:cNvSpPr>
+          <p:nvPr>
+            <p:ph type="sldImg"/>
+          </p:nvPr>
+        </p:nvSpPr>
+        <p:spPr/>
+      </p:sp>
+      <p:sp>
+        <p:nvSpPr>
+          <p:cNvPr id="3" name="Notes Placeholder 2"/>
+          <p:cNvSpPr>
+            <a:spLocks noGrp="1"/>
+          </p:cNvSpPr>
+          <p:nvPr>
+            <p:ph type="body" idx="1"/>
+          </p:nvPr>
+        </p:nvSpPr>
+        <p:spPr/>
+        <p:txBody>
+          <a:bodyPr/>
+          <a:lstStyle/>
+          <a:p>
+            <a:r>
+              <a:rPr lang="en-US" dirty="0"/>
+              <a:t>Espacio para la parte del integrante 2.</a:t>
+            </a:r>
+          </a:p>
+        </p:txBody>
+      </p:sp>
+      <p:sp>
+        <p:nvSpPr>
+          <p:cNvPr id="4" name="Slide Number Placeholder 3"/>
+          <p:cNvSpPr>
+            <a:spLocks noGrp="1"/>
+          </p:cNvSpPr>
+          <p:nvPr>
+            <p:ph type="sldNum" sz="quarter" idx="10"/>
+          </p:nvPr>
+        </p:nvSpPr>
+        <p:spPr/>
+        <p:txBody>
+          <a:bodyPr/>
+          <a:lstStyle/>
+          <a:p>
+            <a:fld id="{F7021451-1387-4CA6-816F-3879F97B5CBC}" type="slidenum">
+              <a:rPr lang="en-US"/>
+              <a:t>12</a:t>
+            </a:fld>
+            <a:endParaRPr lang="en-US"/>
+          </a:p>
+        </p:txBody>
+      </p:sp>
+    </p:spTree>
+    <p:extLst>
+      <p:ext uri="{BB962C8B-B14F-4D97-AF65-F5344CB8AC3E}">
+        <p14:creationId xmlns:p14="http://schemas.microsoft.com/office/powerpoint/2010/main" val="2373013882"/>
+      </p:ext>
+    </p:extLst>
+  </p:cSld>
+  <p:clrMapOvr>
+    <a:masterClrMapping/>
+  </p:clrMapOvr>
+</p:notes>
+</file>
+
 <file path=ppt/notesSlides/notesSlide2.xml><?xml version="1.0" encoding="utf-8"?>
 <p:notes xmlns:a="http://schemas.openxmlformats.org/drawingml/2006/main" xmlns:r="http://schemas.openxmlformats.org/officeDocument/2006/relationships" xmlns:p="http://schemas.openxmlformats.org/presentationml/2006/main">
   <p:cSld>
@@ -728,7 +824,15 @@
           <a:p>
             <a:r>
               <a:rPr lang="en-US" dirty="0"/>
-              <a:t>Los cuatro primeros (tarjetas claras) miden el resultado comercial; los dos oscuros miden el envío, núcleo del negocio. Valores calculados sobre los datos actuales. No hay KPI de margen porque no existen costos.</a:t>
+              <a:t>Los cuatro primeros (tarjetas claras) miden el </a:t>
+            </a:r>
+            <a:r>
+              <a:rPr lang="en-US" dirty="0" err="1"/>
+              <a:t>resultado</a:t>
+            </a:r>
+            <a:r>
+              <a:rPr lang="en-US" dirty="0"/>
+              <a:t> comercial; los dos oscuros miden el envío, núcleo del negocio. Valores calculados sobre los datos actuales. No hay KPI de margen porque no existen costos.</a:t>
             </a:r>
           </a:p>
         </p:txBody>
@@ -815,7 +919,15 @@
           <a:p>
             <a:r>
               <a:rPr lang="en-US" dirty="0"/>
-              <a:t>Si el grano fuera la orden, perderíamos el análisis por producto y categoría.</a:t>
+              <a:t>Si el grano fuera la orden, perderíamos el análisis por </a:t>
+            </a:r>
+            <a:r>
+              <a:rPr lang="en-US" dirty="0" err="1"/>
+              <a:t>producto</a:t>
+            </a:r>
+            <a:r>
+              <a:rPr lang="en-US" dirty="0"/>
+              <a:t> y categoría.</a:t>
             </a:r>
           </a:p>
         </p:txBody>
@@ -1076,7 +1188,15 @@
           <a:p>
             <a:r>
               <a:rPr lang="en-US" dirty="0"/>
-              <a:t>Pregunta probable en la interrogación: ¿por qué no incluyeron territorios? Porque necesitaríamos una tabla puente y las ventas se contarían una vez por cada territorio del empleado.</a:t>
+              <a:t>Pregunta probable en la interrogación: ¿por qué no incluyeron territorios? Porque necesitaríamos una tabla puente y las ventas se contarían una vez por cada territorio del </a:t>
+            </a:r>
+            <a:r>
+              <a:rPr lang="en-US" dirty="0" err="1"/>
+              <a:t>empleado</a:t>
+            </a:r>
+            <a:r>
+              <a:rPr lang="en-US" dirty="0"/>
+              <a:t>.</a:t>
             </a:r>
           </a:p>
         </p:txBody>
@@ -2617,7 +2737,7 @@
                 <a:ea typeface="Georgia" pitchFamily="18" charset="-122"/>
                 <a:cs typeface="Georgia" pitchFamily="18" charset="-120"/>
               </a:rPr>
-              <a:t>Carga con SSIS</a:t>
+              <a:t>Arquitectura y dimensiones</a:t>
             </a:r>
             <a:endParaRPr lang="en-US" sz="3200" dirty="0"/>
           </a:p>
@@ -2631,8 +2751,8 @@
         </p:nvSpPr>
         <p:spPr>
           <a:xfrm>
-            <a:off x="812800" y="1899921"/>
-            <a:ext cx="10883392" cy="614680"/>
+            <a:off x="812800" y="1899920"/>
+            <a:ext cx="10883392" cy="3830315"/>
           </a:xfrm>
           <a:prstGeom prst="rect">
             <a:avLst/>
@@ -2653,16 +2773,216 @@
               <a:buNone/>
             </a:pPr>
             <a:r>
+              <a:rPr lang="en-US" b="1" dirty="0">
+                <a:latin typeface="+mj-lt"/>
+              </a:rPr>
+              <a:t>Flujo de control (Orquestación en SSIS)</a:t>
+            </a:r>
+          </a:p>
+          <a:p>
+            <a:pPr marL="285750" indent="-285750" algn="l">
+              <a:lnSpc>
+                <a:spcPts val="2320"/>
+              </a:lnSpc>
+              <a:buFont typeface="Arial" panose="020B0604020202020204" pitchFamily="34" charset="0"/>
+              <a:buChar char="•"/>
+            </a:pPr>
+            <a:r>
+              <a:rPr lang="en-US" sz="1600" b="1" dirty="0">
+                <a:latin typeface="+mj-lt"/>
+              </a:rPr>
+              <a:t>Limpieza: </a:t>
+            </a:r>
+            <a:r>
               <a:rPr lang="en-US" sz="1600" dirty="0">
-                <a:solidFill>
-                  <a:srgbClr val="3E4A57"/>
-                </a:solidFill>
-                <a:latin typeface="Arial" pitchFamily="34" charset="0"/>
-                <a:ea typeface="Arial" pitchFamily="34" charset="-122"/>
-                <a:cs typeface="Arial" pitchFamily="34" charset="-120"/>
-              </a:rPr>
-              <a:t>[Sección a completar: flujo de control, carga de dimensiones, Lookups y columnas derivadas de FactVentas, manejo de FechaEnvio nula y resultado de la validación.]</a:t>
-            </a:r>
+                <a:latin typeface="+mj-lt"/>
+              </a:rPr>
+              <a:t>Tarea SQL inicial con DELETE (En lugar de TRUNCATE) para respetar las Foreign Keys.</a:t>
+            </a:r>
+          </a:p>
+          <a:p>
+            <a:pPr marL="285750" indent="-285750" algn="l">
+              <a:lnSpc>
+                <a:spcPts val="2320"/>
+              </a:lnSpc>
+              <a:buFont typeface="Arial" panose="020B0604020202020204" pitchFamily="34" charset="0"/>
+              <a:buChar char="•"/>
+            </a:pPr>
+            <a:r>
+              <a:rPr lang="en-US" sz="1600" b="1" dirty="0">
+                <a:latin typeface="+mj-lt"/>
+              </a:rPr>
+              <a:t>Carga Paralela: </a:t>
+            </a:r>
+            <a:r>
+              <a:rPr lang="en-US" sz="1600" dirty="0">
+                <a:latin typeface="+mj-lt"/>
+              </a:rPr>
+              <a:t>4 tareas de flujos de datos para Cliente, Transportista, Empleado y Producto.</a:t>
+            </a:r>
+          </a:p>
+          <a:p>
+            <a:pPr marL="285750" indent="-285750" algn="l">
+              <a:lnSpc>
+                <a:spcPts val="2320"/>
+              </a:lnSpc>
+              <a:buFont typeface="Arial" panose="020B0604020202020204" pitchFamily="34" charset="0"/>
+              <a:buChar char="•"/>
+            </a:pPr>
+            <a:r>
+              <a:rPr lang="en-US" sz="1600" b="1" dirty="0">
+                <a:latin typeface="+mj-lt"/>
+              </a:rPr>
+              <a:t>Secuencia: </a:t>
+            </a:r>
+            <a:r>
+              <a:rPr lang="en-US" sz="1600" dirty="0">
+                <a:latin typeface="+mj-lt"/>
+              </a:rPr>
+              <a:t>La tabla de hechos y la validacion se ejecutan solo después de que las dimensiones están pobladas.</a:t>
+            </a:r>
+          </a:p>
+          <a:p>
+            <a:pPr marL="285750" indent="-285750" algn="l">
+              <a:lnSpc>
+                <a:spcPts val="2320"/>
+              </a:lnSpc>
+              <a:buFont typeface="Arial" panose="020B0604020202020204" pitchFamily="34" charset="0"/>
+              <a:buChar char="•"/>
+            </a:pPr>
+            <a:endParaRPr lang="en-US" sz="1600" dirty="0">
+              <a:latin typeface="+mj-lt"/>
+            </a:endParaRPr>
+          </a:p>
+          <a:p>
+            <a:pPr algn="l">
+              <a:lnSpc>
+                <a:spcPts val="2320"/>
+              </a:lnSpc>
+            </a:pPr>
+            <a:r>
+              <a:rPr lang="en-US" b="1" dirty="0">
+                <a:latin typeface="+mj-lt"/>
+              </a:rPr>
+              <a:t>Transformaciones clave en Dimensiones</a:t>
+            </a:r>
+          </a:p>
+          <a:p>
+            <a:pPr marL="285750" indent="-285750" algn="l">
+              <a:lnSpc>
+                <a:spcPts val="2320"/>
+              </a:lnSpc>
+              <a:buFont typeface="Arial" panose="020B0604020202020204" pitchFamily="34" charset="0"/>
+              <a:buChar char="•"/>
+            </a:pPr>
+            <a:r>
+              <a:rPr lang="en-US" sz="1600" b="1" dirty="0">
+                <a:latin typeface="+mj-lt"/>
+              </a:rPr>
+              <a:t>DimProducto</a:t>
+            </a:r>
+            <a:r>
+              <a:rPr lang="en-US" sz="1600" dirty="0">
+                <a:latin typeface="+mj-lt"/>
+              </a:rPr>
+              <a:t> (Desnormalización): Se usó un commando SQL en el origen con INNER JOIN entre </a:t>
+            </a:r>
+            <a:r>
+              <a:rPr lang="en-US" sz="1600" b="1" dirty="0">
+                <a:latin typeface="+mj-lt"/>
+              </a:rPr>
+              <a:t>Productos</a:t>
+            </a:r>
+            <a:r>
+              <a:rPr lang="en-US" sz="1600" dirty="0">
+                <a:latin typeface="+mj-lt"/>
+              </a:rPr>
+              <a:t>, </a:t>
+            </a:r>
+            <a:r>
+              <a:rPr lang="en-US" sz="1600" b="1" dirty="0">
+                <a:latin typeface="+mj-lt"/>
+              </a:rPr>
+              <a:t>Categorias</a:t>
+            </a:r>
+            <a:r>
+              <a:rPr lang="en-US" sz="1600" dirty="0">
+                <a:latin typeface="+mj-lt"/>
+              </a:rPr>
+              <a:t> y </a:t>
+            </a:r>
+            <a:r>
+              <a:rPr lang="en-US" sz="1600" b="1" dirty="0">
+                <a:latin typeface="+mj-lt"/>
+              </a:rPr>
+              <a:t>Proveedores</a:t>
+            </a:r>
+            <a:r>
+              <a:rPr lang="en-US" sz="1600" dirty="0">
+                <a:latin typeface="+mj-lt"/>
+              </a:rPr>
+              <a:t> para mantener el esquema Estrella.</a:t>
+            </a:r>
+          </a:p>
+          <a:p>
+            <a:pPr marL="285750" indent="-285750" algn="l">
+              <a:lnSpc>
+                <a:spcPts val="2320"/>
+              </a:lnSpc>
+              <a:buFont typeface="Arial" panose="020B0604020202020204" pitchFamily="34" charset="0"/>
+              <a:buChar char="•"/>
+            </a:pPr>
+            <a:r>
+              <a:rPr lang="en-US" sz="1600" b="1" dirty="0">
+                <a:latin typeface="+mj-lt"/>
+              </a:rPr>
+              <a:t>DimEmpleado:</a:t>
+            </a:r>
+            <a:r>
+              <a:rPr lang="en-US" sz="1600" dirty="0">
+                <a:latin typeface="+mj-lt"/>
+              </a:rPr>
+              <a:t> se usó el componente de columna derivada para concatenar </a:t>
+            </a:r>
+            <a:r>
+              <a:rPr lang="en-US" sz="1600" b="1" dirty="0">
+                <a:latin typeface="+mj-lt"/>
+              </a:rPr>
+              <a:t>Nombre</a:t>
+            </a:r>
+            <a:r>
+              <a:rPr lang="en-US" sz="1600" dirty="0">
+                <a:latin typeface="+mj-lt"/>
+              </a:rPr>
+              <a:t> + </a:t>
+            </a:r>
+            <a:r>
+              <a:rPr lang="en-US" sz="1600" b="1" dirty="0">
+                <a:latin typeface="+mj-lt"/>
+              </a:rPr>
+              <a:t>Apellido</a:t>
+            </a:r>
+            <a:r>
+              <a:rPr lang="en-US" sz="1600" dirty="0">
+                <a:latin typeface="+mj-lt"/>
+              </a:rPr>
+              <a:t> y generar </a:t>
+            </a:r>
+            <a:r>
+              <a:rPr lang="en-US" sz="1600" b="1" dirty="0">
+                <a:latin typeface="+mj-lt"/>
+              </a:rPr>
+              <a:t>NombreCompleto</a:t>
+            </a:r>
+          </a:p>
+          <a:p>
+            <a:pPr marL="285750" indent="-285750" algn="l">
+              <a:lnSpc>
+                <a:spcPts val="2320"/>
+              </a:lnSpc>
+              <a:buFont typeface="Arial" panose="020B0604020202020204" pitchFamily="34" charset="0"/>
+              <a:buChar char="•"/>
+            </a:pPr>
             <a:endParaRPr lang="en-US" sz="1600" dirty="0"/>
           </a:p>
         </p:txBody>
@@ -2712,6 +3032,384 @@
         </p:txBody>
       </p:sp>
     </p:spTree>
+  </p:cSld>
+  <p:clrMapOvr>
+    <a:masterClrMapping/>
+  </p:clrMapOvr>
+</p:sld>
+</file>
+
+<file path=ppt/slides/slide12.xml><?xml version="1.0" encoding="utf-8"?>
+<p:sld xmlns:a="http://schemas.openxmlformats.org/drawingml/2006/main" xmlns:r="http://schemas.openxmlformats.org/officeDocument/2006/relationships" xmlns:p="http://schemas.openxmlformats.org/presentationml/2006/main">
+  <p:cSld>
+    <p:bg>
+      <p:bgPr>
+        <a:solidFill>
+          <a:srgbClr val="F7F6F2"/>
+        </a:solidFill>
+        <a:effectLst/>
+      </p:bgPr>
+    </p:bg>
+    <p:spTree>
+      <p:nvGrpSpPr>
+        <p:cNvPr id="1" name=""/>
+        <p:cNvGrpSpPr/>
+        <p:nvPr/>
+      </p:nvGrpSpPr>
+      <p:grpSpPr>
+        <a:xfrm>
+          <a:off x="0" y="0"/>
+          <a:ext cx="0" cy="0"/>
+          <a:chOff x="0" y="0"/>
+          <a:chExt cx="0" cy="0"/>
+        </a:xfrm>
+      </p:grpSpPr>
+      <p:sp>
+        <p:nvSpPr>
+          <p:cNvPr id="2" name="Text 0"/>
+          <p:cNvSpPr/>
+          <p:nvPr/>
+        </p:nvSpPr>
+        <p:spPr>
+          <a:xfrm>
+            <a:off x="812800" y="812800"/>
+            <a:ext cx="10883392" cy="238760"/>
+          </a:xfrm>
+          <a:prstGeom prst="rect">
+            <a:avLst/>
+          </a:prstGeom>
+          <a:noFill/>
+          <a:ln/>
+        </p:spPr>
+        <p:txBody>
+          <a:bodyPr wrap="square" lIns="0" tIns="0" rIns="0" bIns="0" rtlCol="0" anchor="t">
+            <a:normAutofit/>
+          </a:bodyPr>
+          <a:lstStyle/>
+          <a:p>
+            <a:pPr marL="0" indent="0" algn="l">
+              <a:lnSpc>
+                <a:spcPts val="1680"/>
+              </a:lnSpc>
+              <a:buNone/>
+            </a:pPr>
+            <a:r>
+              <a:rPr lang="en-US" sz="1200" kern="0" spc="150" dirty="0">
+                <a:solidFill>
+                  <a:srgbClr val="A0521A"/>
+                </a:solidFill>
+                <a:latin typeface="Arial" pitchFamily="34" charset="0"/>
+                <a:ea typeface="Arial" pitchFamily="34" charset="-122"/>
+                <a:cs typeface="Arial" pitchFamily="34" charset="-120"/>
+              </a:rPr>
+              <a:t>PROCESO ETL</a:t>
+            </a:r>
+          </a:p>
+        </p:txBody>
+      </p:sp>
+      <p:sp>
+        <p:nvSpPr>
+          <p:cNvPr id="3" name="Text 1"/>
+          <p:cNvSpPr>
+            <a:spLocks noGrp="1"/>
+          </p:cNvSpPr>
+          <p:nvPr>
+            <p:ph type="title"/>
+          </p:nvPr>
+        </p:nvSpPr>
+        <p:spPr>
+          <a:xfrm>
+            <a:off x="812800" y="1127764"/>
+            <a:ext cx="10883392" cy="492760"/>
+          </a:xfrm>
+          <a:prstGeom prst="rect">
+            <a:avLst/>
+          </a:prstGeom>
+          <a:noFill/>
+          <a:ln/>
+        </p:spPr>
+        <p:txBody>
+          <a:bodyPr wrap="square" lIns="0" tIns="0" rIns="0" bIns="0" rtlCol="0" anchor="t">
+            <a:normAutofit/>
+          </a:bodyPr>
+          <a:lstStyle/>
+          <a:p>
+            <a:pPr marL="0" indent="0" algn="l">
+              <a:lnSpc>
+                <a:spcPts val="3680"/>
+              </a:lnSpc>
+              <a:buNone/>
+            </a:pPr>
+            <a:r>
+              <a:rPr lang="en-US" sz="2800" b="1" dirty="0"/>
+              <a:t>Tabla De Hechos y Validaciones</a:t>
+            </a:r>
+          </a:p>
+        </p:txBody>
+      </p:sp>
+      <p:sp>
+        <p:nvSpPr>
+          <p:cNvPr id="4" name="Text 2"/>
+          <p:cNvSpPr/>
+          <p:nvPr/>
+        </p:nvSpPr>
+        <p:spPr>
+          <a:xfrm>
+            <a:off x="590858" y="2014225"/>
+            <a:ext cx="10883392" cy="3830315"/>
+          </a:xfrm>
+          <a:prstGeom prst="rect">
+            <a:avLst/>
+          </a:prstGeom>
+          <a:noFill/>
+          <a:ln/>
+        </p:spPr>
+        <p:txBody>
+          <a:bodyPr wrap="square" lIns="0" tIns="0" rIns="0" bIns="0" rtlCol="0" anchor="t">
+            <a:normAutofit/>
+          </a:bodyPr>
+          <a:lstStyle/>
+          <a:p>
+            <a:pPr algn="l">
+              <a:lnSpc>
+                <a:spcPts val="2320"/>
+              </a:lnSpc>
+            </a:pPr>
+            <a:r>
+              <a:rPr lang="en-US" b="1" dirty="0"/>
+              <a:t>Carga de FactVentas</a:t>
+            </a:r>
+          </a:p>
+          <a:p>
+            <a:pPr marL="285750" indent="-285750" algn="l">
+              <a:lnSpc>
+                <a:spcPts val="2320"/>
+              </a:lnSpc>
+              <a:buFont typeface="Arial" panose="020B0604020202020204" pitchFamily="34" charset="0"/>
+              <a:buChar char="•"/>
+            </a:pPr>
+            <a:r>
+              <a:rPr lang="en-US" sz="1600" b="1" dirty="0"/>
+              <a:t>Cálculos: </a:t>
+            </a:r>
+            <a:r>
+              <a:rPr lang="en-US" sz="1600" dirty="0"/>
+              <a:t>3 columnas derivadas generan </a:t>
+            </a:r>
+            <a:r>
+              <a:rPr lang="en-US" sz="1600" b="1" dirty="0"/>
+              <a:t>MontoBruto</a:t>
+            </a:r>
+            <a:r>
+              <a:rPr lang="en-US" sz="1600" dirty="0"/>
+              <a:t>, </a:t>
+            </a:r>
+            <a:r>
+              <a:rPr lang="en-US" sz="1600" b="1" dirty="0"/>
+              <a:t>MontoDescuento</a:t>
+            </a:r>
+            <a:r>
+              <a:rPr lang="en-US" sz="1600" dirty="0"/>
+              <a:t>, </a:t>
+            </a:r>
+            <a:r>
+              <a:rPr lang="en-US" sz="1600" b="1" dirty="0"/>
+              <a:t>MontoNeto</a:t>
+            </a:r>
+            <a:r>
+              <a:rPr lang="en-US" sz="1600" dirty="0"/>
+              <a:t> y </a:t>
+            </a:r>
+            <a:r>
+              <a:rPr lang="en-US" sz="1600" b="1" dirty="0"/>
+              <a:t>DiasDespacho </a:t>
+            </a:r>
+            <a:r>
+              <a:rPr lang="en-US" sz="1600" dirty="0"/>
+              <a:t>(asignando 0 si la fecha de envío es nula).</a:t>
+            </a:r>
+          </a:p>
+          <a:p>
+            <a:pPr marL="285750" indent="-285750" algn="l">
+              <a:lnSpc>
+                <a:spcPts val="2320"/>
+              </a:lnSpc>
+              <a:buFont typeface="Arial" panose="020B0604020202020204" pitchFamily="34" charset="0"/>
+              <a:buChar char="•"/>
+            </a:pPr>
+            <a:r>
+              <a:rPr lang="en-US" sz="1600" b="1" dirty="0"/>
+              <a:t>Lookups en Cascada: </a:t>
+            </a:r>
+            <a:r>
+              <a:rPr lang="en-US" sz="1600" dirty="0"/>
+              <a:t>6 componentes de Búsqueda </a:t>
+            </a:r>
+          </a:p>
+          <a:p>
+            <a:pPr marL="285750" indent="-285750" algn="l">
+              <a:lnSpc>
+                <a:spcPts val="2320"/>
+              </a:lnSpc>
+              <a:buFont typeface="Arial" panose="020B0604020202020204" pitchFamily="34" charset="0"/>
+              <a:buChar char="•"/>
+            </a:pPr>
+            <a:r>
+              <a:rPr lang="en-US" sz="1600" b="1" dirty="0"/>
+              <a:t>Manejo de fechas nulas: </a:t>
+            </a:r>
+            <a:r>
+              <a:rPr lang="en-US" sz="1600" dirty="0"/>
+              <a:t>Conversion a formato entero </a:t>
+            </a:r>
+            <a:r>
+              <a:rPr lang="en-US" sz="1600" b="1" dirty="0"/>
+              <a:t>AAAAMMDD</a:t>
+            </a:r>
+            <a:r>
+              <a:rPr lang="en-US" sz="1600" dirty="0"/>
+              <a:t>. Las 21 órdenes sin envío se mapean a la clave </a:t>
+            </a:r>
+            <a:r>
+              <a:rPr lang="en-US" sz="1600" b="1" dirty="0"/>
+              <a:t>-1 (“Sin Fecha”) </a:t>
+            </a:r>
+            <a:r>
+              <a:rPr lang="en-US" sz="1600" dirty="0"/>
+              <a:t>de </a:t>
+            </a:r>
+            <a:r>
+              <a:rPr lang="en-US" sz="1600" b="1" dirty="0"/>
+              <a:t>DimTiempo.</a:t>
+            </a:r>
+          </a:p>
+          <a:p>
+            <a:pPr marL="285750" indent="-285750" algn="l">
+              <a:lnSpc>
+                <a:spcPts val="2320"/>
+              </a:lnSpc>
+              <a:buFont typeface="Arial" panose="020B0604020202020204" pitchFamily="34" charset="0"/>
+              <a:buChar char="•"/>
+            </a:pPr>
+            <a:endParaRPr lang="en-US" sz="1600" dirty="0"/>
+          </a:p>
+          <a:p>
+            <a:pPr algn="l">
+              <a:lnSpc>
+                <a:spcPts val="2320"/>
+              </a:lnSpc>
+            </a:pPr>
+            <a:r>
+              <a:rPr lang="en-US" sz="1600" b="1" dirty="0"/>
+              <a:t>Validación automática</a:t>
+            </a:r>
+          </a:p>
+          <a:p>
+            <a:pPr marL="285750" indent="-285750" algn="l">
+              <a:lnSpc>
+                <a:spcPts val="2320"/>
+              </a:lnSpc>
+              <a:buFont typeface="Arial" panose="020B0604020202020204" pitchFamily="34" charset="0"/>
+              <a:buChar char="•"/>
+            </a:pPr>
+            <a:r>
+              <a:rPr lang="en-US" sz="1600" b="1" dirty="0"/>
+              <a:t>Tarea final que ejecuta 02_validacion_carga-sql comparando Origen vs DW.</a:t>
+            </a:r>
+          </a:p>
+          <a:p>
+            <a:pPr marL="285750" indent="-285750" algn="l">
+              <a:lnSpc>
+                <a:spcPts val="2320"/>
+              </a:lnSpc>
+              <a:buFont typeface="Arial" panose="020B0604020202020204" pitchFamily="34" charset="0"/>
+              <a:buChar char="•"/>
+            </a:pPr>
+            <a:r>
+              <a:rPr lang="en-US" sz="1600" b="1" dirty="0"/>
+              <a:t>Resultado: 2.155</a:t>
+            </a:r>
+            <a:r>
+              <a:rPr lang="en-US" sz="1600" dirty="0"/>
+              <a:t> filas cargadas, </a:t>
+            </a:r>
+            <a:r>
+              <a:rPr lang="en-US" sz="1600" b="1" dirty="0"/>
+              <a:t>$1,265,792.76</a:t>
+            </a:r>
+            <a:r>
+              <a:rPr lang="en-US" sz="1600" dirty="0"/>
+              <a:t> en ventas netas, </a:t>
+            </a:r>
+            <a:r>
+              <a:rPr lang="en-US" sz="1600" b="1" dirty="0"/>
+              <a:t>0 filas huerfanas</a:t>
+            </a:r>
+            <a:r>
+              <a:rPr lang="en-US" sz="1600" dirty="0"/>
+              <a:t>. Todos los controles en “</a:t>
+            </a:r>
+            <a:r>
+              <a:rPr lang="en-US" sz="1600" b="1" dirty="0"/>
+              <a:t>OK</a:t>
+            </a:r>
+            <a:r>
+              <a:rPr lang="en-US" sz="1600" dirty="0"/>
+              <a:t>”</a:t>
+            </a:r>
+          </a:p>
+        </p:txBody>
+      </p:sp>
+      <p:sp>
+        <p:nvSpPr>
+          <p:cNvPr id="5" name="Text 3"/>
+          <p:cNvSpPr/>
+          <p:nvPr/>
+        </p:nvSpPr>
+        <p:spPr>
+          <a:xfrm>
+            <a:off x="812800" y="6238242"/>
+            <a:ext cx="10883392" cy="238760"/>
+          </a:xfrm>
+          <a:prstGeom prst="rect">
+            <a:avLst/>
+          </a:prstGeom>
+          <a:noFill/>
+          <a:ln/>
+        </p:spPr>
+        <p:txBody>
+          <a:bodyPr wrap="square" lIns="0" tIns="0" rIns="0" bIns="0" rtlCol="0" anchor="t">
+            <a:normAutofit/>
+          </a:bodyPr>
+          <a:lstStyle/>
+          <a:p>
+            <a:pPr marL="0" indent="0" algn="l">
+              <a:lnSpc>
+                <a:spcPts val="1680"/>
+              </a:lnSpc>
+              <a:buNone/>
+            </a:pPr>
+            <a:r>
+              <a:rPr lang="en-US" sz="1200" dirty="0">
+                <a:solidFill>
+                  <a:srgbClr val="7A8591"/>
+                </a:solidFill>
+                <a:latin typeface="Arial" pitchFamily="34" charset="0"/>
+                <a:ea typeface="Arial" pitchFamily="34" charset="-122"/>
+                <a:cs typeface="Arial" pitchFamily="34" charset="-120"/>
+              </a:rPr>
+              <a:t>11</a:t>
+            </a:r>
+            <a:endParaRPr lang="en-US" sz="1200" dirty="0"/>
+          </a:p>
+        </p:txBody>
+      </p:sp>
+    </p:spTree>
+    <p:extLst>
+      <p:ext uri="{BB962C8B-B14F-4D97-AF65-F5344CB8AC3E}">
+        <p14:creationId xmlns:p14="http://schemas.microsoft.com/office/powerpoint/2010/main" val="566188247"/>
+      </p:ext>
+    </p:extLst>
   </p:cSld>
   <p:clrMapOvr>
     <a:masterClrMapping/>
@@ -2918,7 +3616,29 @@
                 <a:ea typeface="Arial" pitchFamily="34" charset="-122"/>
                 <a:cs typeface="Arial" pitchFamily="34" charset="-120"/>
               </a:rPr>
-              <a:t>Kent Foods vende alimentos por envío y creció rápido. Su base transaccional registra órdenes, productos, clientes, empleados y transportistas.</a:t>
+              <a:t>Kent Foods vende alimentos por envío y creció rápido. Su base transaccional registra órdenes, </a:t>
+            </a:r>
+            <a:r>
+              <a:rPr lang="en-US" sz="1600" dirty="0" err="1">
+                <a:solidFill>
+                  <a:srgbClr val="3E4A57"/>
+                </a:solidFill>
+                <a:latin typeface="Arial" pitchFamily="34" charset="0"/>
+                <a:ea typeface="Arial" pitchFamily="34" charset="-122"/>
+                <a:cs typeface="Arial" pitchFamily="34" charset="-120"/>
+              </a:rPr>
+              <a:t>productos</a:t>
+            </a:r>
+            <a:r>
+              <a:rPr lang="en-US" sz="1600" dirty="0">
+                <a:solidFill>
+                  <a:srgbClr val="3E4A57"/>
+                </a:solidFill>
+                <a:latin typeface="Arial" pitchFamily="34" charset="0"/>
+                <a:ea typeface="Arial" pitchFamily="34" charset="-122"/>
+                <a:cs typeface="Arial" pitchFamily="34" charset="-120"/>
+              </a:rPr>
+              <a:t>, clientes, empleados y transportistas.</a:t>
             </a:r>
             <a:endParaRPr lang="en-US" sz="1600" dirty="0"/>
           </a:p>
@@ -4278,7 +4998,29 @@
                           <a:ea typeface="Arial" pitchFamily="34" charset="-122"/>
                           <a:cs typeface="Arial" pitchFamily="34" charset="-120"/>
                         </a:rPr>
-                        <a:t>Igual al país del cliente en el 100 %</a:t>
+                        <a:t>Igual al país del </a:t>
+                      </a:r>
+                      <a:r>
+                        <a:rPr lang="en-US" sz="1300" dirty="0" err="1">
+                          <a:solidFill>
+                            <a:srgbClr val="3E4A57"/>
+                          </a:solidFill>
+                          <a:latin typeface="Arial" pitchFamily="34" charset="0"/>
+                          <a:ea typeface="Arial" pitchFamily="34" charset="-122"/>
+                          <a:cs typeface="Arial" pitchFamily="34" charset="-120"/>
+                        </a:rPr>
+                        <a:t>cliente</a:t>
+                      </a:r>
+                      <a:r>
+                        <a:rPr lang="en-US" sz="1300" dirty="0">
+                          <a:solidFill>
+                            <a:srgbClr val="3E4A57"/>
+                          </a:solidFill>
+                          <a:latin typeface="Arial" pitchFamily="34" charset="0"/>
+                          <a:ea typeface="Arial" pitchFamily="34" charset="-122"/>
+                          <a:cs typeface="Arial" pitchFamily="34" charset="-120"/>
+                        </a:rPr>
+                        <a:t> en el 100 %</a:t>
                       </a:r>
                       <a:endParaRPr lang="en-US" sz="1300" dirty="0">
                         <a:latin typeface="Arial" charset="0"/>
@@ -4700,7 +5442,29 @@
                           <a:ea typeface="Arial" pitchFamily="34" charset="-122"/>
                           <a:cs typeface="Arial" pitchFamily="34" charset="-120"/>
                         </a:rPr>
-                        <a:t>No hay costo de producto ni flete</a:t>
+                        <a:t>No hay costo de </a:t>
+                      </a:r>
+                      <a:r>
+                        <a:rPr lang="en-US" sz="1300" dirty="0" err="1">
+                          <a:solidFill>
+                            <a:srgbClr val="3E4A57"/>
+                          </a:solidFill>
+                          <a:latin typeface="Arial" pitchFamily="34" charset="0"/>
+                          <a:ea typeface="Arial" pitchFamily="34" charset="-122"/>
+                          <a:cs typeface="Arial" pitchFamily="34" charset="-120"/>
+                        </a:rPr>
+                        <a:t>producto</a:t>
+                      </a:r>
+                      <a:r>
+                        <a:rPr lang="en-US" sz="1300" dirty="0">
+                          <a:solidFill>
+                            <a:srgbClr val="3E4A57"/>
+                          </a:solidFill>
+                          <a:latin typeface="Arial" pitchFamily="34" charset="0"/>
+                          <a:ea typeface="Arial" pitchFamily="34" charset="-122"/>
+                          <a:cs typeface="Arial" pitchFamily="34" charset="-120"/>
+                        </a:rPr>
+                        <a:t> ni flete</a:t>
                       </a:r>
                       <a:endParaRPr lang="en-US" sz="1300" dirty="0">
                         <a:latin typeface="Arial" charset="0"/>
@@ -5561,7 +6325,18 @@
                 <a:ea typeface="Arial" pitchFamily="34" charset="-122"/>
                 <a:cs typeface="Arial" pitchFamily="34" charset="-120"/>
               </a:rPr>
-              <a:t>Ventas por empleado</a:t>
+              <a:t>Ventas por </a:t>
+            </a:r>
+            <a:r>
+              <a:rPr lang="en-US" sz="1400" b="1" dirty="0" err="1">
+                <a:solidFill>
+                  <a:srgbClr val="1B2A3A"/>
+                </a:solidFill>
+                <a:latin typeface="Arial" pitchFamily="34" charset="0"/>
+                <a:ea typeface="Arial" pitchFamily="34" charset="-122"/>
+                <a:cs typeface="Arial" pitchFamily="34" charset="-120"/>
+              </a:rPr>
+              <a:t>empleado</a:t>
             </a:r>
             <a:endParaRPr lang="en-US" sz="1400" dirty="0"/>
           </a:p>
@@ -6348,7 +7123,29 @@
                 <a:ea typeface="Arial" pitchFamily="34" charset="-122"/>
                 <a:cs typeface="Arial" pitchFamily="34" charset="-120"/>
               </a:rPr>
-              <a:t>Una fila por producto en una orden</a:t>
+              <a:t>Una fila por </a:t>
+            </a:r>
+            <a:r>
+              <a:rPr lang="en-US" sz="2200" b="1" dirty="0" err="1">
+                <a:solidFill>
+                  <a:srgbClr val="1B2A3A"/>
+                </a:solidFill>
+                <a:latin typeface="Arial" pitchFamily="34" charset="0"/>
+                <a:ea typeface="Arial" pitchFamily="34" charset="-122"/>
+                <a:cs typeface="Arial" pitchFamily="34" charset="-120"/>
+              </a:rPr>
+              <a:t>producto</a:t>
+            </a:r>
+            <a:r>
+              <a:rPr lang="en-US" sz="2200" b="1" dirty="0">
+                <a:solidFill>
+                  <a:srgbClr val="1B2A3A"/>
+                </a:solidFill>
+                <a:latin typeface="Arial" pitchFamily="34" charset="0"/>
+                <a:ea typeface="Arial" pitchFamily="34" charset="-122"/>
+                <a:cs typeface="Arial" pitchFamily="34" charset="-120"/>
+              </a:rPr>
+              <a:t> en una orden</a:t>
             </a:r>
             <a:endParaRPr lang="en-US" sz="2200" dirty="0"/>
           </a:p>
@@ -6392,7 +7189,29 @@
                 <a:ea typeface="Arial" pitchFamily="34" charset="-122"/>
                 <a:cs typeface="Arial" pitchFamily="34" charset="-120"/>
               </a:rPr>
-              <a:t>Equivale a una línea de DetalleOrden. Es el nivel más fino: desde ahí se agrega a orden, cliente o mes, pero no al revés. Coincide 1 a 1 con el origen: 2.155 filas esperadas.</a:t>
+              <a:t>Equivale a una línea de DetalleOrden. Es el nivel más fino: desde ahí se agrega a orden, </a:t>
+            </a:r>
+            <a:r>
+              <a:rPr lang="en-US" sz="1500" dirty="0" err="1">
+                <a:solidFill>
+                  <a:srgbClr val="3E4A57"/>
+                </a:solidFill>
+                <a:latin typeface="Arial" pitchFamily="34" charset="0"/>
+                <a:ea typeface="Arial" pitchFamily="34" charset="-122"/>
+                <a:cs typeface="Arial" pitchFamily="34" charset="-120"/>
+              </a:rPr>
+              <a:t>cliente</a:t>
+            </a:r>
+            <a:r>
+              <a:rPr lang="en-US" sz="1500" dirty="0">
+                <a:solidFill>
+                  <a:srgbClr val="3E4A57"/>
+                </a:solidFill>
+                <a:latin typeface="Arial" pitchFamily="34" charset="0"/>
+                <a:ea typeface="Arial" pitchFamily="34" charset="-122"/>
+                <a:cs typeface="Arial" pitchFamily="34" charset="-120"/>
+              </a:rPr>
+              <a:t> o mes, pero no al revés. Coincide 1 a 1 con el origen: 2.155 filas esperadas.</a:t>
             </a:r>
             <a:endParaRPr lang="en-US" sz="1500" dirty="0"/>
           </a:p>
@@ -9084,7 +9903,18 @@
                 <a:ea typeface="Arial" pitchFamily="34" charset="-122"/>
                 <a:cs typeface="Arial" pitchFamily="34" charset="-120"/>
               </a:rPr>
-              <a:t>Destino de envío: redundante con el país del cliente</a:t>
+              <a:t>Destino de envío: redundante con el país del </a:t>
+            </a:r>
+            <a:r>
+              <a:rPr lang="en-US" sz="1500" dirty="0" err="1">
+                <a:solidFill>
+                  <a:srgbClr val="3E4A57"/>
+                </a:solidFill>
+                <a:latin typeface="Arial" pitchFamily="34" charset="0"/>
+                <a:ea typeface="Arial" pitchFamily="34" charset="-122"/>
+                <a:cs typeface="Arial" pitchFamily="34" charset="-120"/>
+              </a:rPr>
+              <a:t>cliente</a:t>
             </a:r>
             <a:endParaRPr lang="en-US" sz="1500" dirty="0"/>
           </a:p>

</xml_diff>